<commit_message>
Adopt CNN normalized-RN60-MSE routes and refresh paper artifacts
</commit_message>
<xml_diff>
--- a/figures/main/fig6_architecture_editable.pptx
+++ b/figures/main/fig6_architecture_editable.pptx
@@ -484,7 +484,7 @@
       </p:sp>
       <p:sp>
         <p:nvSpPr>
-          <p:cNvPr id="10" name="Patch MLP"/>
+          <p:cNvPr id="10" name="CNN"/>
           <p:cNvSpPr/>
           <p:nvPr/>
         </p:nvSpPr>
@@ -525,7 +525,7 @@
                 <a:ea typeface="Arial"/>
                 <a:cs typeface="Arial"/>
               </a:rPr>
-              <a:t>Patch MLP</a:t>
+              <a:t>CNN</a:t>
             </a:r>
             <a:endParaRPr lang="en-US" sz="1200" b="1" dirty="0"/>
           </a:p>
@@ -638,7 +638,7 @@
       </p:cxnSp>
       <p:cxnSp>
         <p:nvCxnSpPr>
-          <p:cNvPr id="14" name="HSR to Patch MLP segment 1"/>
+          <p:cNvPr id="14" name="HSR to CNN segment 1"/>
           <p:cNvCxnSpPr>
             <a:cxnSpLocks/>
             <a:stCxn id="9" idx="3"/>
@@ -666,7 +666,7 @@
       </p:cxnSp>
       <p:cxnSp>
         <p:nvCxnSpPr>
-          <p:cNvPr id="15" name="Patch MLP to RN60 segment 1"/>
+          <p:cNvPr id="15" name="CNN to RN60 segment 1"/>
           <p:cNvCxnSpPr>
             <a:cxnSpLocks/>
             <a:stCxn id="10" idx="3"/>

</xml_diff>

<commit_message>
Update figure reproduction and streamline public package
</commit_message>
<xml_diff>
--- a/figures/main/fig6_architecture_editable.pptx
+++ b/figures/main/fig6_architecture_editable.pptx
@@ -779,7 +779,7 @@
             <a:solidFill>
               <a:srgbClr val="7B5EA7"/>
             </a:solidFill>
-            <a:prstDash val="dash"/>
+            <a:prstDash val="solid"/>
             <a:round/>
           </a:ln>
         </p:spPr>
@@ -845,7 +845,7 @@
             <a:solidFill>
               <a:srgbClr val="008F7A"/>
             </a:solidFill>
-            <a:prstDash val="dash"/>
+            <a:prstDash val="solid"/>
             <a:round/>
           </a:ln>
         </p:spPr>
@@ -929,7 +929,7 @@
             <a:solidFill>
               <a:srgbClr val="008F7A"/>
             </a:solidFill>
-            <a:prstDash val="dash"/>
+            <a:prstDash val="solid"/>
             <a:round/>
             <a:tailEnd type="triangle" w="med" len="med"/>
           </a:ln>
@@ -1291,7 +1291,7 @@
             <a:solidFill>
               <a:srgbClr val="7B5EA7"/>
             </a:solidFill>
-            <a:prstDash val="dash"/>
+            <a:prstDash val="solid"/>
             <a:round/>
           </a:ln>
         </p:spPr>
@@ -2230,36 +2230,13 @@
                 <a:solidFill>
                   <a:srgbClr val="25313C"/>
                 </a:solidFill>
-                <a:latin typeface="+mn-lt"/>
-                <a:ea typeface="나눔스퀘어 Bold" panose="020B0600000101010101" pitchFamily="50" charset="-127"/>
-                <a:cs typeface="Arial"/>
-              </a:rPr>
-              <a:t>Gauge</a:t>
-            </a:r>
-            <a:endParaRPr lang="en-US" sz="1200" b="1" dirty="0">
-              <a:latin typeface="+mn-lt"/>
-              <a:ea typeface="나눔스퀘어 Bold" panose="020B0600000101010101" pitchFamily="50" charset="-127"/>
-            </a:endParaRPr>
-          </a:p>
-          <a:p>
-            <a:pPr algn="ctr">
-              <a:buNone/>
-            </a:pPr>
-            <a:r>
-              <a:rPr lang="en-US" sz="1200" b="1" dirty="0">
-                <a:solidFill>
-                  <a:srgbClr val="25313C"/>
-                </a:solidFill>
-                <a:latin typeface="+mn-lt"/>
-                <a:ea typeface="나눔스퀘어 Bold" panose="020B0600000101010101" pitchFamily="50" charset="-127"/>
-                <a:cs typeface="Arial"/>
-              </a:rPr>
-              <a:t>RN60</a:t>
-            </a:r>
-            <a:endParaRPr lang="en-US" sz="1200" b="1" dirty="0">
-              <a:latin typeface="+mn-lt"/>
-              <a:ea typeface="나눔스퀘어 Bold" panose="020B0600000101010101" pitchFamily="50" charset="-127"/>
-            </a:endParaRPr>
+                <a:latin typeface="Arial"/>
+                <a:ea typeface="Arial"/>
+                <a:cs typeface="Arial"/>
+              </a:rPr>
+              <a:t>Gauge RN60</a:t>
+            </a:r>
+            <a:endParaRPr lang="en-US" sz="1200" b="1" dirty="0"/>
           </a:p>
         </p:txBody>
       </p:sp>
@@ -2500,7 +2477,7 @@
             <a:solidFill>
               <a:srgbClr val="7B5EA7"/>
             </a:solidFill>
-            <a:prstDash val="dash"/>
+            <a:prstDash val="solid"/>
             <a:round/>
             <a:tailEnd type="triangle" w="med" len="med"/>
           </a:ln>
@@ -2548,7 +2525,7 @@
             <a:solidFill>
               <a:srgbClr val="7B5EA7"/>
             </a:solidFill>
-            <a:prstDash val="dash"/>
+            <a:prstDash val="solid"/>
             <a:round/>
             <a:tailEnd type="triangle" w="med" len="med"/>
           </a:ln>

</xml_diff>